<commit_message>
feat(pptx): add template inspection and materialization
</commit_message>
<xml_diff>
--- a/plugin/tests/fixtures/pptx/ecosystem_bc/templates/external-and-ole.pptx
+++ b/plugin/tests/fixtures/pptx/ecosystem_bc/templates/external-and-ole.pptx
@@ -521,6 +521,9 @@
             <a:off x="457200" y="1402080"/>
             <a:ext cx="8229600" cy="5090160"/>
           </a:xfrm>
+          <a:prstGeom prst="rect">
+            <a:avLst/>
+          </a:prstGeom>
           <a:solidFill>
             <a:srgbClr val="FFFFFF"/>
           </a:solidFill>
@@ -529,9 +532,6 @@
               <a:srgbClr val="D9E2F3"/>
             </a:solidFill>
           </a:ln>
-          <a:prstGeom prst="rect">
-            <a:avLst/>
-          </a:prstGeom>
         </p:spPr>
         <p:txBody>
           <a:bodyPr/>
@@ -555,10 +555,10 @@
           <p:cNvGraphicFramePr/>
           <p:nvPr/>
         </p:nvGraphicFramePr>
-        <a:xfrm>
+        <p:xfrm>
           <a:off x="457200" y="1402080"/>
           <a:ext cx="8229600" cy="5090160"/>
-        </a:xfrm>
+        </p:xfrm>
         <a:graphic>
           <a:graphicData uri="http://schemas.openxmlformats.org/drawingml/2006/chart">
             <c:chart r:id="rIdChart"/>
@@ -663,11 +663,25 @@
           <a:schemeClr val="phClr"/>
         </a:solidFill>
         <a:gradFill>
-          <a:gsLst/>
+          <a:gsLst>
+            <a:gs pos="0">
+              <a:schemeClr val="phClr"/>
+            </a:gs>
+            <a:gs pos="100000">
+              <a:schemeClr val="phClr"/>
+            </a:gs>
+          </a:gsLst>
           <a:lin ang="0" scaled="0"/>
         </a:gradFill>
         <a:gradFill>
-          <a:gsLst/>
+          <a:gsLst>
+            <a:gs pos="0">
+              <a:schemeClr val="phClr"/>
+            </a:gs>
+            <a:gs pos="100000">
+              <a:schemeClr val="phClr"/>
+            </a:gs>
+          </a:gsLst>
           <a:lin ang="0" scaled="0"/>
         </a:gradFill>
       </a:fillStyleLst>

</xml_diff>

<commit_message>
feat(pptx): add template inspection and materialization (#10)
</commit_message>
<xml_diff>
--- a/plugin/tests/fixtures/pptx/ecosystem_bc/templates/external-and-ole.pptx
+++ b/plugin/tests/fixtures/pptx/ecosystem_bc/templates/external-and-ole.pptx
@@ -521,6 +521,9 @@
             <a:off x="457200" y="1402080"/>
             <a:ext cx="8229600" cy="5090160"/>
           </a:xfrm>
+          <a:prstGeom prst="rect">
+            <a:avLst/>
+          </a:prstGeom>
           <a:solidFill>
             <a:srgbClr val="FFFFFF"/>
           </a:solidFill>
@@ -529,9 +532,6 @@
               <a:srgbClr val="D9E2F3"/>
             </a:solidFill>
           </a:ln>
-          <a:prstGeom prst="rect">
-            <a:avLst/>
-          </a:prstGeom>
         </p:spPr>
         <p:txBody>
           <a:bodyPr/>
@@ -555,10 +555,10 @@
           <p:cNvGraphicFramePr/>
           <p:nvPr/>
         </p:nvGraphicFramePr>
-        <a:xfrm>
+        <p:xfrm>
           <a:off x="457200" y="1402080"/>
           <a:ext cx="8229600" cy="5090160"/>
-        </a:xfrm>
+        </p:xfrm>
         <a:graphic>
           <a:graphicData uri="http://schemas.openxmlformats.org/drawingml/2006/chart">
             <c:chart r:id="rIdChart"/>
@@ -663,11 +663,25 @@
           <a:schemeClr val="phClr"/>
         </a:solidFill>
         <a:gradFill>
-          <a:gsLst/>
+          <a:gsLst>
+            <a:gs pos="0">
+              <a:schemeClr val="phClr"/>
+            </a:gs>
+            <a:gs pos="100000">
+              <a:schemeClr val="phClr"/>
+            </a:gs>
+          </a:gsLst>
           <a:lin ang="0" scaled="0"/>
         </a:gradFill>
         <a:gradFill>
-          <a:gsLst/>
+          <a:gsLst>
+            <a:gs pos="0">
+              <a:schemeClr val="phClr"/>
+            </a:gs>
+            <a:gs pos="100000">
+              <a:schemeClr val="phClr"/>
+            </a:gs>
+          </a:gsLst>
           <a:lin ang="0" scaled="0"/>
         </a:gradFill>
       </a:fillStyleLst>

</xml_diff>